<commit_message>
docs: use lagharilabs.com in presentation branding
</commit_message>
<xml_diff>
--- a/marketing/adversaria-story/output/adversaria-one-slide.pptx
+++ b/marketing/adversaria-story/output/adversaria-one-slide.pptx
@@ -2,13 +2,13 @@
 <file path=ppt/presentation.xml><?xml version="1.0" encoding="utf-8"?>
 <p:presentation xmlns:p="http://schemas.openxmlformats.org/presentationml/2006/main">
   <p:sldMasterIdLst>
-    <p:sldMasterId xmlns:r="http://schemas.openxmlformats.org/officeDocument/2006/relationships" id="2147483648" r:id="Re4ab16425fc042ae"/>
+    <p:sldMasterId xmlns:r="http://schemas.openxmlformats.org/officeDocument/2006/relationships" id="2147483648" r:id="R13bf535d716a4125"/>
   </p:sldMasterIdLst>
   <p:notesMasterIdLst>
-    <p:notesMasterId xmlns:r="http://schemas.openxmlformats.org/officeDocument/2006/relationships" r:id="Rad03d5abe02747e6"/>
+    <p:notesMasterId xmlns:r="http://schemas.openxmlformats.org/officeDocument/2006/relationships" r:id="R4540192359a740dd"/>
   </p:notesMasterIdLst>
   <p:sldIdLst>
-    <p:sldId xmlns:r="http://schemas.openxmlformats.org/officeDocument/2006/relationships" id="256" r:id="Ra2913203763e416f"/>
+    <p:sldId xmlns:r="http://schemas.openxmlformats.org/officeDocument/2006/relationships" id="256" r:id="R82f8be8e0f8b4448"/>
   </p:sldIdLst>
   <p:sldSz cx="15240000" cy="8572500"/>
   <p:notesSz cx="6858000" cy="9144000"/>
@@ -550,7 +550,7 @@
   </p:cSld>
   <p:clrMap bg1="lt1" tx1="dk1" bg2="lt2" tx2="dk2" accent1="accent1" accent2="accent2" accent3="accent3" accent4="accent4" accent5="accent5" accent6="accent6" hlink="hlink" folHlink="folHlink"/>
   <p:sldLayoutIdLst>
-    <p:sldLayoutId xmlns:r="http://schemas.openxmlformats.org/officeDocument/2006/relationships" id="2147483649" r:id="R38dbe0e2328342a0"/>
+    <p:sldLayoutId xmlns:r="http://schemas.openxmlformats.org/officeDocument/2006/relationships" id="2147483649" r:id="Rc32422c3f8e746c5"/>
   </p:sldLayoutIdLst>
   <p:txStyles>
     <p:titleStyle>
@@ -1101,7 +1101,7 @@
           <p:cNvPr id="10" name="Laghari Labs frame">
             <a:extLst xmlns:a="http://schemas.openxmlformats.org/drawingml/2006/main">
               <a:ext uri="{FF2B5EF4-FFF2-40B4-BE49-F238E27FC236}">
-                <a16:creationId xmlns:a16="http://schemas.microsoft.com/office/drawing/2014/main" id="{5E717E25-0DA6-47E8-9EB8-DCF2FF342EE4}"/>
+                <a16:creationId xmlns:a16="http://schemas.microsoft.com/office/drawing/2014/main" id="{824ABE56-2827-404B-8A9F-F7B090B02B3C}"/>
               </a:ext>
             </a:extLst>
           </p:cNvPr>
@@ -1131,7 +1131,7 @@
           <p:cNvPr id="2" name="Editable text 0">
             <a:extLst xmlns:a="http://schemas.openxmlformats.org/drawingml/2006/main">
               <a:ext uri="{FF2B5EF4-FFF2-40B4-BE49-F238E27FC236}">
-                <a16:creationId xmlns:a16="http://schemas.microsoft.com/office/drawing/2014/main" id="{5D600E06-ED8D-440D-A611-610A7D51BC46}"/>
+                <a16:creationId xmlns:a16="http://schemas.microsoft.com/office/drawing/2014/main" id="{2718D11A-6185-4A4A-9EDA-8B2D2CD60914}"/>
               </a:ext>
             </a:extLst>
           </p:cNvPr>
@@ -1192,7 +1192,7 @@
           <p:cNvPr id="3" name="Editable text 1">
             <a:extLst xmlns:a="http://schemas.openxmlformats.org/drawingml/2006/main">
               <a:ext uri="{FF2B5EF4-FFF2-40B4-BE49-F238E27FC236}">
-                <a16:creationId xmlns:a16="http://schemas.microsoft.com/office/drawing/2014/main" id="{258124EB-1225-4BB0-AF45-68A9EE7B546F}"/>
+                <a16:creationId xmlns:a16="http://schemas.microsoft.com/office/drawing/2014/main" id="{089518E5-8AA9-405D-A7A6-32009BEBE92D}"/>
               </a:ext>
             </a:extLst>
           </p:cNvPr>
@@ -1253,7 +1253,7 @@
           <p:cNvPr id="4" name="Editable text 2">
             <a:extLst xmlns:a="http://schemas.openxmlformats.org/drawingml/2006/main">
               <a:ext uri="{FF2B5EF4-FFF2-40B4-BE49-F238E27FC236}">
-                <a16:creationId xmlns:a16="http://schemas.microsoft.com/office/drawing/2014/main" id="{7A3B835A-EB3E-4D4D-90DA-587EE42A0712}"/>
+                <a16:creationId xmlns:a16="http://schemas.microsoft.com/office/drawing/2014/main" id="{5DA30F5E-B32E-451C-9F06-472D8167CFA5}"/>
               </a:ext>
             </a:extLst>
           </p:cNvPr>
@@ -1314,7 +1314,7 @@
           <p:cNvPr id="5" name="Brand highlight 3">
             <a:extLst xmlns:a="http://schemas.openxmlformats.org/drawingml/2006/main">
               <a:ext uri="{FF2B5EF4-FFF2-40B4-BE49-F238E27FC236}">
-                <a16:creationId xmlns:a16="http://schemas.microsoft.com/office/drawing/2014/main" id="{B158D748-07B9-4BDC-A65E-C5F712A26F66}"/>
+                <a16:creationId xmlns:a16="http://schemas.microsoft.com/office/drawing/2014/main" id="{BEE26D18-9A12-4A0C-B796-CCE9A231A3CF}"/>
               </a:ext>
             </a:extLst>
           </p:cNvPr>
@@ -1344,7 +1344,7 @@
           <p:cNvPr id="6" name="Brand highlight 4">
             <a:extLst xmlns:a="http://schemas.openxmlformats.org/drawingml/2006/main">
               <a:ext uri="{FF2B5EF4-FFF2-40B4-BE49-F238E27FC236}">
-                <a16:creationId xmlns:a16="http://schemas.microsoft.com/office/drawing/2014/main" id="{4001E8E7-4F0E-4882-8350-C076340141A6}"/>
+                <a16:creationId xmlns:a16="http://schemas.microsoft.com/office/drawing/2014/main" id="{6FEDCA0E-6CC3-4755-96CF-6452FAFB7839}"/>
               </a:ext>
             </a:extLst>
           </p:cNvPr>
@@ -1376,7 +1376,7 @@
           <p:cNvPr id="7" name="Editable text 5">
             <a:extLst xmlns:a="http://schemas.openxmlformats.org/drawingml/2006/main">
               <a:ext uri="{FF2B5EF4-FFF2-40B4-BE49-F238E27FC236}">
-                <a16:creationId xmlns:a16="http://schemas.microsoft.com/office/drawing/2014/main" id="{E0AF6D7C-50AB-4BCB-8CEA-766CC48E17E2}"/>
+                <a16:creationId xmlns:a16="http://schemas.microsoft.com/office/drawing/2014/main" id="{FE6A2CE8-6B70-4864-8013-0C92E261F1A9}"/>
               </a:ext>
             </a:extLst>
           </p:cNvPr>
@@ -1437,7 +1437,7 @@
           <p:cNvPr id="8" name="Editable text 6">
             <a:extLst xmlns:a="http://schemas.openxmlformats.org/drawingml/2006/main">
               <a:ext uri="{FF2B5EF4-FFF2-40B4-BE49-F238E27FC236}">
-                <a16:creationId xmlns:a16="http://schemas.microsoft.com/office/drawing/2014/main" id="{F8B0FDF9-DAB8-49EE-97CD-EE42C256A0A0}"/>
+                <a16:creationId xmlns:a16="http://schemas.microsoft.com/office/drawing/2014/main" id="{F021CD9C-BAE1-4DB2-951A-1C76FD701E3F}"/>
               </a:ext>
             </a:extLst>
           </p:cNvPr>
@@ -1488,7 +1488,7 @@
                 <a:ea typeface="Silkscreen"/>
                 <a:cs typeface="Silkscreen"/>
               </a:rPr>
-              <a:t>LaghariLabs.io</a:t>
+              <a:t>LaghariLabs.com</a:t>
             </a:r>
           </a:p>
         </p:txBody>
@@ -1498,7 +1498,7 @@
           <p:cNvPr id="9" name="Editable text 7">
             <a:extLst xmlns:a="http://schemas.openxmlformats.org/drawingml/2006/main">
               <a:ext uri="{FF2B5EF4-FFF2-40B4-BE49-F238E27FC236}">
-                <a16:creationId xmlns:a16="http://schemas.microsoft.com/office/drawing/2014/main" id="{9D4A3731-1FEF-4065-8680-C386F9E73386}"/>
+                <a16:creationId xmlns:a16="http://schemas.microsoft.com/office/drawing/2014/main" id="{4F6CBCDE-3E3B-48E6-8907-51B0FD469D82}"/>
               </a:ext>
             </a:extLst>
           </p:cNvPr>
@@ -1557,7 +1557,7 @@
     </p:spTree>
     <p:extLst>
       <p:ext uri="{BB962C8B-B14F-4D97-AF65-F5344CB8AC3E}">
-        <p14:creationId xmlns:p14="http://schemas.microsoft.com/office/powerpoint/2010/main" val="755333072"/>
+        <p14:creationId xmlns:p14="http://schemas.microsoft.com/office/powerpoint/2010/main" val="1487583861"/>
       </p:ext>
     </p:extLst>
   </p:cSld>

</xml_diff>